<commit_message>
Clarify strands-to-products relationship on the one-pager
States in the products band that each product contributes across
multiple strands and columns do not pair one-to-one, and names the
dashed link as COGCON's nesting in the caption — preventing the
implied column-by-column mapping between the two rows.

Co-Authored-By: Claude Fable 5 <noreply@anthropic.com>
Claude-Session: https://claude.ai/code/session_01YLo1WfwUDkbwfJEF3ZNVbB
</commit_message>
<xml_diff>
--- a/output/combat-mindset-onepager.pptx
+++ b/output/combat-mindset-onepager.pptx
@@ -3807,7 +3807,7 @@
         <p:spPr>
           <a:xfrm>
             <a:off x="521208" y="5852160"/>
-            <a:ext cx="11155680" cy="182880"/>
+            <a:ext cx="5486400" cy="182880"/>
           </a:xfrm>
           <a:prstGeom prst="rect">
             <a:avLst/>
@@ -3839,7 +3839,46 @@
       </p:sp>
       <p:sp>
         <p:nvSpPr>
-          <p:cNvPr id="92" name="Shape 89"/>
+          <p:cNvPr id="92" name="Text 89"/>
+          <p:cNvSpPr/>
+          <p:nvPr/>
+        </p:nvSpPr>
+        <p:spPr>
+          <a:xfrm>
+            <a:off x="5989320" y="5852160"/>
+            <a:ext cx="5687568" cy="182880"/>
+          </a:xfrm>
+          <a:prstGeom prst="rect">
+            <a:avLst/>
+          </a:prstGeom>
+          <a:noFill/>
+          <a:ln/>
+        </p:spPr>
+        <p:txBody>
+          <a:bodyPr wrap="square" lIns="0" tIns="0" rIns="0" bIns="0" rtlCol="0" anchor="ctr"/>
+          <a:lstStyle/>
+          <a:p>
+            <a:pPr algn="r" indent="0" marL="0">
+              <a:buNone/>
+            </a:pPr>
+            <a:r>
+              <a:rPr lang="en-US" sz="720" i="1" dirty="0">
+                <a:solidFill>
+                  <a:srgbClr val="CDD2B7"/>
+                </a:solidFill>
+                <a:latin typeface="Arial" pitchFamily="34" charset="0"/>
+                <a:ea typeface="Arial" pitchFamily="34" charset="-122"/>
+                <a:cs typeface="Arial" pitchFamily="34" charset="-120"/>
+              </a:rPr>
+              <a:t>each product contributes across multiple strands — columns do not pair one-to-one</a:t>
+            </a:r>
+            <a:endParaRPr lang="en-US" sz="720" dirty="0"/>
+          </a:p>
+        </p:txBody>
+      </p:sp>
+      <p:sp>
+        <p:nvSpPr>
+          <p:cNvPr id="93" name="Shape 90"/>
           <p:cNvSpPr/>
           <p:nvPr/>
         </p:nvSpPr>
@@ -3864,7 +3903,7 @@
       </p:sp>
       <p:sp>
         <p:nvSpPr>
-          <p:cNvPr id="93" name="Text 90"/>
+          <p:cNvPr id="94" name="Text 91"/>
           <p:cNvSpPr/>
           <p:nvPr/>
         </p:nvSpPr>
@@ -3903,7 +3942,7 @@
       </p:sp>
       <p:sp>
         <p:nvSpPr>
-          <p:cNvPr id="94" name="Shape 91"/>
+          <p:cNvPr id="95" name="Shape 92"/>
           <p:cNvSpPr/>
           <p:nvPr/>
         </p:nvSpPr>
@@ -3928,7 +3967,7 @@
       </p:sp>
       <p:sp>
         <p:nvSpPr>
-          <p:cNvPr id="95" name="Text 92"/>
+          <p:cNvPr id="96" name="Text 93"/>
           <p:cNvSpPr/>
           <p:nvPr/>
         </p:nvSpPr>
@@ -3967,7 +4006,7 @@
       </p:sp>
       <p:sp>
         <p:nvSpPr>
-          <p:cNvPr id="96" name="Shape 93"/>
+          <p:cNvPr id="97" name="Shape 94"/>
           <p:cNvSpPr/>
           <p:nvPr/>
         </p:nvSpPr>
@@ -3992,7 +4031,7 @@
       </p:sp>
       <p:sp>
         <p:nvSpPr>
-          <p:cNvPr id="97" name="Text 94"/>
+          <p:cNvPr id="98" name="Text 95"/>
           <p:cNvSpPr/>
           <p:nvPr/>
         </p:nvSpPr>
@@ -4048,7 +4087,7 @@
       </p:sp>
       <p:sp>
         <p:nvSpPr>
-          <p:cNvPr id="98" name="Shape 95"/>
+          <p:cNvPr id="99" name="Shape 96"/>
           <p:cNvSpPr/>
           <p:nvPr/>
         </p:nvSpPr>
@@ -4073,7 +4112,7 @@
       </p:sp>
       <p:sp>
         <p:nvSpPr>
-          <p:cNvPr id="99" name="Text 96"/>
+          <p:cNvPr id="100" name="Text 97"/>
           <p:cNvSpPr/>
           <p:nvPr/>
         </p:nvSpPr>
@@ -4112,7 +4151,7 @@
       </p:sp>
       <p:sp>
         <p:nvSpPr>
-          <p:cNvPr id="100" name="Shape 97"/>
+          <p:cNvPr id="101" name="Shape 98"/>
           <p:cNvSpPr/>
           <p:nvPr/>
         </p:nvSpPr>
@@ -4137,7 +4176,7 @@
       </p:sp>
       <p:sp>
         <p:nvSpPr>
-          <p:cNvPr id="101" name="Text 98"/>
+          <p:cNvPr id="102" name="Text 99"/>
           <p:cNvSpPr/>
           <p:nvPr/>
         </p:nvSpPr>
@@ -4176,7 +4215,7 @@
       </p:sp>
       <p:sp>
         <p:nvSpPr>
-          <p:cNvPr id="102" name="Shape 99"/>
+          <p:cNvPr id="103" name="Shape 100"/>
           <p:cNvSpPr/>
           <p:nvPr/>
         </p:nvSpPr>
@@ -4201,7 +4240,7 @@
       </p:sp>
       <p:sp>
         <p:nvSpPr>
-          <p:cNvPr id="103" name="Text 100"/>
+          <p:cNvPr id="104" name="Text 101"/>
           <p:cNvSpPr/>
           <p:nvPr/>
         </p:nvSpPr>
@@ -4240,7 +4279,7 @@
       </p:sp>
       <p:sp>
         <p:nvSpPr>
-          <p:cNvPr id="104" name="Shape 101"/>
+          <p:cNvPr id="105" name="Shape 102"/>
           <p:cNvSpPr/>
           <p:nvPr/>
         </p:nvSpPr>
@@ -4265,7 +4304,7 @@
       </p:sp>
       <p:sp>
         <p:nvSpPr>
-          <p:cNvPr id="105" name="Text 102"/>
+          <p:cNvPr id="106" name="Text 103"/>
           <p:cNvSpPr/>
           <p:nvPr/>
         </p:nvSpPr>
@@ -4304,7 +4343,7 @@
       </p:sp>
       <p:sp>
         <p:nvSpPr>
-          <p:cNvPr id="106" name="Shape 103"/>
+          <p:cNvPr id="107" name="Shape 104"/>
           <p:cNvSpPr/>
           <p:nvPr/>
         </p:nvSpPr>
@@ -4328,7 +4367,7 @@
       </p:sp>
       <p:sp>
         <p:nvSpPr>
-          <p:cNvPr id="107" name="Text 104"/>
+          <p:cNvPr id="108" name="Text 105"/>
           <p:cNvSpPr/>
           <p:nvPr/>
         </p:nvSpPr>
@@ -4359,7 +4398,7 @@
                 <a:ea typeface="Arial" pitchFamily="34" charset="-122"/>
                 <a:cs typeface="Arial" pitchFamily="34" charset="-120"/>
               </a:rPr>
-              <a:t>COGCON develops selected elements of Performance Under Pressure — not a complete Combat Mindset programme or a validated operational-readiness measure.</a:t>
+              <a:t>COGCON MVP is nested within the performance-cognition strand (dashed link). It develops selected elements of Performance Under Pressure — not a complete Combat Mindset programme or a validated operational-readiness measure.</a:t>
             </a:r>
             <a:endParaRPr lang="en-US" sz="680" dirty="0"/>
           </a:p>
@@ -4367,7 +4406,7 @@
       </p:sp>
       <p:sp>
         <p:nvSpPr>
-          <p:cNvPr id="108" name="Text 105"/>
+          <p:cNvPr id="109" name="Text 106"/>
           <p:cNvSpPr/>
           <p:nvPr/>
         </p:nvSpPr>

</xml_diff>

<commit_message>
Align paper with slide decisions: pillars, phases 0-4 (v0.4)
Sweeps the way-forward paper to capability pillars terminology,
removes the standalone MVP integration trial phase (COGCON's completed
feasibility trials in live training now enter Phase 1 as mapped
evidence), renumbers report back as Phase 4, and adjusts the programme
recommendation accordingly. Version to Draft v0.4. Updates both
one-pager slides to match: five-step programme, pillars wording and
centred arrow glyphs on the landscape version, v0.4 document control
throughout.

Co-Authored-By: Claude Fable 5 <noreply@anthropic.com>
Claude-Session: https://claude.ai/code/session_01YLo1WfwUDkbwfJEF3ZNVbB
</commit_message>
<xml_diff>
--- a/output/combat-mindset-onepager.pptx
+++ b/output/combat-mindset-onepager.pptx
@@ -1026,7 +1026,7 @@
                 <a:ea typeface="Arial" pitchFamily="34" charset="-122"/>
                 <a:cs typeface="Arial" pitchFamily="34" charset="-120"/>
               </a:rPr>
-              <a:t>NZALC / Human Performance Cell   ·   NZALC/HPC 2026   ·   Draft v0.3   ·   July 2026</a:t>
+              <a:t>NZALC / Human Performance Cell   ·   NZALC/HPC 2026   ·   Draft v0.4   ·   July 2026</a:t>
             </a:r>
             <a:endParaRPr lang="en-US" sz="650" dirty="0"/>
           </a:p>
@@ -2206,7 +2206,7 @@
                 <a:ea typeface="Arial" pitchFamily="34" charset="-122"/>
                 <a:cs typeface="Arial" pitchFamily="34" charset="-120"/>
               </a:rPr>
-              <a:t>Organises:  definitions  ·  desired outcomes  ·  capability strands  ·  developmental progression  ·  products and methods  ·  delivery  ·  governance  ·  evidence  ·  assurance</a:t>
+              <a:t>Organises:  definitions  ·  desired outcomes  ·  capability pillars  ·  developmental progression  ·  products and methods  ·  delivery  ·  governance  ·  evidence  ·  assurance</a:t>
             </a:r>
             <a:endParaRPr lang="en-US" sz="750" dirty="0"/>
           </a:p>
@@ -2819,7 +2819,7 @@
         <p:spPr>
           <a:xfrm>
             <a:off x="7699248" y="3566160"/>
-            <a:ext cx="624840" cy="219456"/>
+            <a:ext cx="758952" cy="219456"/>
           </a:xfrm>
           <a:prstGeom prst="chevron">
             <a:avLst/>
@@ -2839,7 +2839,7 @@
         <p:spPr>
           <a:xfrm>
             <a:off x="7699248" y="3566160"/>
-            <a:ext cx="624840" cy="219456"/>
+            <a:ext cx="758952" cy="219456"/>
           </a:xfrm>
           <a:prstGeom prst="rect">
             <a:avLst/>
@@ -2877,8 +2877,8 @@
         </p:nvSpPr>
         <p:spPr>
           <a:xfrm>
-            <a:off x="8369808" y="3566160"/>
-            <a:ext cx="624840" cy="219456"/>
+            <a:off x="8503920" y="3566160"/>
+            <a:ext cx="758952" cy="219456"/>
           </a:xfrm>
           <a:prstGeom prst="chevron">
             <a:avLst/>
@@ -2897,8 +2897,8 @@
         </p:nvSpPr>
         <p:spPr>
           <a:xfrm>
-            <a:off x="8369808" y="3566160"/>
-            <a:ext cx="624840" cy="219456"/>
+            <a:off x="8503920" y="3566160"/>
+            <a:ext cx="758952" cy="219456"/>
           </a:xfrm>
           <a:prstGeom prst="rect">
             <a:avLst/>
@@ -2936,8 +2936,8 @@
         </p:nvSpPr>
         <p:spPr>
           <a:xfrm>
-            <a:off x="9040368" y="3566160"/>
-            <a:ext cx="624840" cy="219456"/>
+            <a:off x="9308592" y="3566160"/>
+            <a:ext cx="758952" cy="219456"/>
           </a:xfrm>
           <a:prstGeom prst="chevron">
             <a:avLst/>
@@ -2956,8 +2956,8 @@
         </p:nvSpPr>
         <p:spPr>
           <a:xfrm>
-            <a:off x="9040368" y="3566160"/>
-            <a:ext cx="624840" cy="219456"/>
+            <a:off x="9308592" y="3566160"/>
+            <a:ext cx="758952" cy="219456"/>
           </a:xfrm>
           <a:prstGeom prst="rect">
             <a:avLst/>
@@ -2995,8 +2995,8 @@
         </p:nvSpPr>
         <p:spPr>
           <a:xfrm>
-            <a:off x="9710928" y="3566160"/>
-            <a:ext cx="624840" cy="219456"/>
+            <a:off x="10113264" y="3566160"/>
+            <a:ext cx="758952" cy="219456"/>
           </a:xfrm>
           <a:prstGeom prst="chevron">
             <a:avLst/>
@@ -3015,8 +3015,8 @@
         </p:nvSpPr>
         <p:spPr>
           <a:xfrm>
-            <a:off x="9710928" y="3566160"/>
-            <a:ext cx="624840" cy="219456"/>
+            <a:off x="10113264" y="3566160"/>
+            <a:ext cx="758952" cy="219456"/>
           </a:xfrm>
           <a:prstGeom prst="rect">
             <a:avLst/>
@@ -3054,21 +3054,16 @@
         </p:nvSpPr>
         <p:spPr>
           <a:xfrm>
-            <a:off x="10381488" y="3566160"/>
-            <a:ext cx="624840" cy="219456"/>
+            <a:off x="10917936" y="3566160"/>
+            <a:ext cx="758952" cy="219456"/>
           </a:xfrm>
           <a:prstGeom prst="chevron">
             <a:avLst/>
           </a:prstGeom>
           <a:solidFill>
-            <a:srgbClr val="FFFFFF"/>
-          </a:solidFill>
-          <a:ln w="12700">
-            <a:solidFill>
-              <a:srgbClr val="3A4B00"/>
-            </a:solidFill>
-            <a:prstDash val="solid"/>
-          </a:ln>
+            <a:srgbClr val="3A4B00"/>
+          </a:solidFill>
+          <a:ln/>
         </p:spPr>
       </p:sp>
       <p:sp>
@@ -3079,8 +3074,8 @@
         </p:nvSpPr>
         <p:spPr>
           <a:xfrm>
-            <a:off x="10381488" y="3566160"/>
-            <a:ext cx="624840" cy="219456"/>
+            <a:off x="10917936" y="3566160"/>
+            <a:ext cx="758952" cy="219456"/>
           </a:xfrm>
           <a:prstGeom prst="rect">
             <a:avLst/>
@@ -3098,13 +3093,13 @@
             <a:r>
               <a:rPr lang="en-US" sz="680" b="1" dirty="0">
                 <a:solidFill>
-                  <a:srgbClr val="3A4B00"/>
-                </a:solidFill>
-                <a:latin typeface="Arial" pitchFamily="34" charset="0"/>
-                <a:ea typeface="Arial" pitchFamily="34" charset="-122"/>
-                <a:cs typeface="Arial" pitchFamily="34" charset="-120"/>
-              </a:rPr>
-              <a:t>TRIAL</a:t>
+                  <a:srgbClr val="FFFFFF"/>
+                </a:solidFill>
+                <a:latin typeface="Arial" pitchFamily="34" charset="0"/>
+                <a:ea typeface="Arial" pitchFamily="34" charset="-122"/>
+                <a:cs typeface="Arial" pitchFamily="34" charset="-120"/>
+              </a:rPr>
+              <a:t>REPORT</a:t>
             </a:r>
             <a:endParaRPr lang="en-US" sz="680" dirty="0"/>
           </a:p>
@@ -3112,66 +3107,7 @@
       </p:sp>
       <p:sp>
         <p:nvSpPr>
-          <p:cNvPr id="68" name="Shape 65"/>
-          <p:cNvSpPr/>
-          <p:nvPr/>
-        </p:nvSpPr>
-        <p:spPr>
-          <a:xfrm>
-            <a:off x="11052048" y="3566160"/>
-            <a:ext cx="624840" cy="219456"/>
-          </a:xfrm>
-          <a:prstGeom prst="chevron">
-            <a:avLst/>
-          </a:prstGeom>
-          <a:solidFill>
-            <a:srgbClr val="3A4B00"/>
-          </a:solidFill>
-          <a:ln/>
-        </p:spPr>
-      </p:sp>
-      <p:sp>
-        <p:nvSpPr>
-          <p:cNvPr id="69" name="Text 66"/>
-          <p:cNvSpPr/>
-          <p:nvPr/>
-        </p:nvSpPr>
-        <p:spPr>
-          <a:xfrm>
-            <a:off x="11052048" y="3566160"/>
-            <a:ext cx="624840" cy="219456"/>
-          </a:xfrm>
-          <a:prstGeom prst="rect">
-            <a:avLst/>
-          </a:prstGeom>
-          <a:noFill/>
-          <a:ln/>
-        </p:spPr>
-        <p:txBody>
-          <a:bodyPr wrap="square" lIns="0" tIns="0" rIns="0" bIns="0" rtlCol="0" anchor="ctr"/>
-          <a:lstStyle/>
-          <a:p>
-            <a:pPr algn="ctr" indent="0" marL="0">
-              <a:buNone/>
-            </a:pPr>
-            <a:r>
-              <a:rPr lang="en-US" sz="680" b="1" dirty="0">
-                <a:solidFill>
-                  <a:srgbClr val="FFFFFF"/>
-                </a:solidFill>
-                <a:latin typeface="Arial" pitchFamily="34" charset="0"/>
-                <a:ea typeface="Arial" pitchFamily="34" charset="-122"/>
-                <a:cs typeface="Arial" pitchFamily="34" charset="-120"/>
-              </a:rPr>
-              <a:t>REPORT</a:t>
-            </a:r>
-            <a:endParaRPr lang="en-US" sz="680" dirty="0"/>
-          </a:p>
-        </p:txBody>
-      </p:sp>
-      <p:sp>
-        <p:nvSpPr>
-          <p:cNvPr id="70" name="Text 67"/>
+          <p:cNvPr id="68" name="Text 65"/>
           <p:cNvSpPr/>
           <p:nvPr/>
         </p:nvSpPr>
@@ -3202,7 +3138,7 @@
                 <a:ea typeface="Arial" pitchFamily="34" charset="-122"/>
                 <a:cs typeface="Arial" pitchFamily="34" charset="-120"/>
               </a:rPr>
-              <a:t>Phase 4 is a limited COGCON MVP integration trial, subject to capacity. Report back November 2026: Framework v1.0, capability and product map, implementation plan.</a:t>
+              <a:t>COGCON’s completed feasibility trials enter Phase 1 as mapped evidence. Report back November 2026: Framework v1.0, capability and product map, implementation plan.</a:t>
             </a:r>
             <a:endParaRPr lang="en-US" sz="730" dirty="0"/>
           </a:p>
@@ -3210,7 +3146,7 @@
       </p:sp>
       <p:sp>
         <p:nvSpPr>
-          <p:cNvPr id="71" name="Shape 68"/>
+          <p:cNvPr id="69" name="Shape 66"/>
           <p:cNvSpPr/>
           <p:nvPr/>
         </p:nvSpPr>
@@ -3230,7 +3166,7 @@
       </p:sp>
       <p:sp>
         <p:nvSpPr>
-          <p:cNvPr id="72" name="Text 69"/>
+          <p:cNvPr id="70" name="Text 67"/>
           <p:cNvSpPr/>
           <p:nvPr/>
         </p:nvSpPr>
@@ -3269,7 +3205,7 @@
       </p:sp>
       <p:sp>
         <p:nvSpPr>
-          <p:cNvPr id="73" name="Text 70"/>
+          <p:cNvPr id="71" name="Text 68"/>
           <p:cNvSpPr/>
           <p:nvPr/>
         </p:nvSpPr>
@@ -3308,7 +3244,7 @@
       </p:sp>
       <p:sp>
         <p:nvSpPr>
-          <p:cNvPr id="74" name="Shape 71"/>
+          <p:cNvPr id="72" name="Shape 69"/>
           <p:cNvSpPr/>
           <p:nvPr/>
         </p:nvSpPr>
@@ -3328,7 +3264,7 @@
       </p:sp>
       <p:sp>
         <p:nvSpPr>
-          <p:cNvPr id="75" name="Text 72"/>
+          <p:cNvPr id="73" name="Text 70"/>
           <p:cNvSpPr/>
           <p:nvPr/>
         </p:nvSpPr>
@@ -3359,7 +3295,7 @@
                 <a:ea typeface="Arial" pitchFamily="34" charset="-122"/>
                 <a:cs typeface="Arial" pitchFamily="34" charset="-120"/>
               </a:rPr>
-              <a:t>CAPABILITY STRANDS — WHAT WE BUILD</a:t>
+              <a:t>CAPABILITY PILLARS — WHAT WE BUILD</a:t>
             </a:r>
             <a:endParaRPr lang="en-US" sz="850" dirty="0"/>
           </a:p>
@@ -3367,7 +3303,7 @@
       </p:sp>
       <p:sp>
         <p:nvSpPr>
-          <p:cNvPr id="76" name="Shape 73"/>
+          <p:cNvPr id="74" name="Shape 71"/>
           <p:cNvSpPr/>
           <p:nvPr/>
         </p:nvSpPr>
@@ -3387,7 +3323,7 @@
       </p:sp>
       <p:sp>
         <p:nvSpPr>
-          <p:cNvPr id="77" name="Text 74"/>
+          <p:cNvPr id="75" name="Text 72"/>
           <p:cNvSpPr/>
           <p:nvPr/>
         </p:nvSpPr>
@@ -3426,7 +3362,7 @@
       </p:sp>
       <p:sp>
         <p:nvSpPr>
-          <p:cNvPr id="78" name="Shape 75"/>
+          <p:cNvPr id="76" name="Shape 73"/>
           <p:cNvSpPr/>
           <p:nvPr/>
         </p:nvSpPr>
@@ -3446,7 +3382,7 @@
       </p:sp>
       <p:sp>
         <p:nvSpPr>
-          <p:cNvPr id="79" name="Text 76"/>
+          <p:cNvPr id="77" name="Text 74"/>
           <p:cNvSpPr/>
           <p:nvPr/>
         </p:nvSpPr>
@@ -3485,7 +3421,7 @@
       </p:sp>
       <p:sp>
         <p:nvSpPr>
-          <p:cNvPr id="80" name="Shape 77"/>
+          <p:cNvPr id="78" name="Shape 75"/>
           <p:cNvSpPr/>
           <p:nvPr/>
         </p:nvSpPr>
@@ -3505,7 +3441,7 @@
       </p:sp>
       <p:sp>
         <p:nvSpPr>
-          <p:cNvPr id="81" name="Text 78"/>
+          <p:cNvPr id="79" name="Text 76"/>
           <p:cNvSpPr/>
           <p:nvPr/>
         </p:nvSpPr>
@@ -3544,7 +3480,7 @@
       </p:sp>
       <p:sp>
         <p:nvSpPr>
-          <p:cNvPr id="82" name="Shape 79"/>
+          <p:cNvPr id="80" name="Shape 77"/>
           <p:cNvSpPr/>
           <p:nvPr/>
         </p:nvSpPr>
@@ -3564,7 +3500,7 @@
       </p:sp>
       <p:sp>
         <p:nvSpPr>
-          <p:cNvPr id="83" name="Text 80"/>
+          <p:cNvPr id="81" name="Text 78"/>
           <p:cNvSpPr/>
           <p:nvPr/>
         </p:nvSpPr>
@@ -3603,7 +3539,7 @@
       </p:sp>
       <p:sp>
         <p:nvSpPr>
-          <p:cNvPr id="84" name="Shape 81"/>
+          <p:cNvPr id="82" name="Shape 79"/>
           <p:cNvSpPr/>
           <p:nvPr/>
         </p:nvSpPr>
@@ -3623,7 +3559,7 @@
       </p:sp>
       <p:sp>
         <p:nvSpPr>
-          <p:cNvPr id="85" name="Text 82"/>
+          <p:cNvPr id="83" name="Text 80"/>
           <p:cNvSpPr/>
           <p:nvPr/>
         </p:nvSpPr>
@@ -3662,7 +3598,7 @@
       </p:sp>
       <p:sp>
         <p:nvSpPr>
-          <p:cNvPr id="86" name="Shape 83"/>
+          <p:cNvPr id="84" name="Shape 81"/>
           <p:cNvSpPr/>
           <p:nvPr/>
         </p:nvSpPr>
@@ -3682,7 +3618,7 @@
       </p:sp>
       <p:sp>
         <p:nvSpPr>
-          <p:cNvPr id="87" name="Text 84"/>
+          <p:cNvPr id="85" name="Text 82"/>
           <p:cNvSpPr/>
           <p:nvPr/>
         </p:nvSpPr>
@@ -3721,7 +3657,7 @@
       </p:sp>
       <p:sp>
         <p:nvSpPr>
-          <p:cNvPr id="88" name="Shape 85"/>
+          <p:cNvPr id="86" name="Shape 83"/>
           <p:cNvSpPr/>
           <p:nvPr/>
         </p:nvSpPr>
@@ -3741,7 +3677,7 @@
       </p:sp>
       <p:sp>
         <p:nvSpPr>
-          <p:cNvPr id="89" name="Text 86"/>
+          <p:cNvPr id="87" name="Text 84"/>
           <p:cNvSpPr/>
           <p:nvPr/>
         </p:nvSpPr>
@@ -3780,7 +3716,7 @@
       </p:sp>
       <p:sp>
         <p:nvSpPr>
-          <p:cNvPr id="90" name="Shape 87"/>
+          <p:cNvPr id="88" name="Shape 85"/>
           <p:cNvSpPr/>
           <p:nvPr/>
         </p:nvSpPr>
@@ -3800,7 +3736,7 @@
       </p:sp>
       <p:sp>
         <p:nvSpPr>
-          <p:cNvPr id="91" name="Text 88"/>
+          <p:cNvPr id="89" name="Text 86"/>
           <p:cNvSpPr/>
           <p:nvPr/>
         </p:nvSpPr>
@@ -3839,7 +3775,7 @@
       </p:sp>
       <p:sp>
         <p:nvSpPr>
-          <p:cNvPr id="92" name="Text 89"/>
+          <p:cNvPr id="90" name="Text 87"/>
           <p:cNvSpPr/>
           <p:nvPr/>
         </p:nvSpPr>
@@ -3870,7 +3806,7 @@
                 <a:ea typeface="Arial" pitchFamily="34" charset="-122"/>
                 <a:cs typeface="Arial" pitchFamily="34" charset="-120"/>
               </a:rPr>
-              <a:t>each product contributes across multiple strands — columns do not pair one-to-one</a:t>
+              <a:t>each product contributes across multiple pillars — columns do not pair one-to-one</a:t>
             </a:r>
             <a:endParaRPr lang="en-US" sz="720" dirty="0"/>
           </a:p>
@@ -3878,7 +3814,7 @@
       </p:sp>
       <p:sp>
         <p:nvSpPr>
-          <p:cNvPr id="93" name="Shape 90"/>
+          <p:cNvPr id="91" name="Shape 88"/>
           <p:cNvSpPr/>
           <p:nvPr/>
         </p:nvSpPr>
@@ -3903,7 +3839,7 @@
       </p:sp>
       <p:sp>
         <p:nvSpPr>
-          <p:cNvPr id="94" name="Text 91"/>
+          <p:cNvPr id="92" name="Text 89"/>
           <p:cNvSpPr/>
           <p:nvPr/>
         </p:nvSpPr>
@@ -3942,7 +3878,7 @@
       </p:sp>
       <p:sp>
         <p:nvSpPr>
-          <p:cNvPr id="95" name="Shape 92"/>
+          <p:cNvPr id="93" name="Shape 90"/>
           <p:cNvSpPr/>
           <p:nvPr/>
         </p:nvSpPr>
@@ -3967,7 +3903,7 @@
       </p:sp>
       <p:sp>
         <p:nvSpPr>
-          <p:cNvPr id="96" name="Text 93"/>
+          <p:cNvPr id="94" name="Text 91"/>
           <p:cNvSpPr/>
           <p:nvPr/>
         </p:nvSpPr>
@@ -4006,7 +3942,7 @@
       </p:sp>
       <p:sp>
         <p:nvSpPr>
-          <p:cNvPr id="97" name="Shape 94"/>
+          <p:cNvPr id="95" name="Shape 92"/>
           <p:cNvSpPr/>
           <p:nvPr/>
         </p:nvSpPr>
@@ -4031,7 +3967,7 @@
       </p:sp>
       <p:sp>
         <p:nvSpPr>
-          <p:cNvPr id="98" name="Text 95"/>
+          <p:cNvPr id="96" name="Text 93"/>
           <p:cNvSpPr/>
           <p:nvPr/>
         </p:nvSpPr>
@@ -4079,7 +4015,7 @@
                 <a:ea typeface="Arial" pitchFamily="34" charset="-122"/>
                 <a:cs typeface="Arial" pitchFamily="34" charset="-120"/>
               </a:rPr>
-              <a:t>Developmental product — performance-cognition strand</a:t>
+              <a:t>Developmental product — performance-cognition pillar</a:t>
             </a:r>
             <a:endParaRPr lang="en-US" sz="740" dirty="0"/>
           </a:p>
@@ -4087,7 +4023,7 @@
       </p:sp>
       <p:sp>
         <p:nvSpPr>
-          <p:cNvPr id="99" name="Shape 96"/>
+          <p:cNvPr id="97" name="Shape 94"/>
           <p:cNvSpPr/>
           <p:nvPr/>
         </p:nvSpPr>
@@ -4112,7 +4048,7 @@
       </p:sp>
       <p:sp>
         <p:nvSpPr>
-          <p:cNvPr id="100" name="Text 97"/>
+          <p:cNvPr id="98" name="Text 95"/>
           <p:cNvSpPr/>
           <p:nvPr/>
         </p:nvSpPr>
@@ -4151,7 +4087,7 @@
       </p:sp>
       <p:sp>
         <p:nvSpPr>
-          <p:cNvPr id="101" name="Shape 98"/>
+          <p:cNvPr id="99" name="Shape 96"/>
           <p:cNvSpPr/>
           <p:nvPr/>
         </p:nvSpPr>
@@ -4176,7 +4112,7 @@
       </p:sp>
       <p:sp>
         <p:nvSpPr>
-          <p:cNvPr id="102" name="Text 99"/>
+          <p:cNvPr id="100" name="Text 97"/>
           <p:cNvSpPr/>
           <p:nvPr/>
         </p:nvSpPr>
@@ -4215,7 +4151,7 @@
       </p:sp>
       <p:sp>
         <p:nvSpPr>
-          <p:cNvPr id="103" name="Shape 100"/>
+          <p:cNvPr id="101" name="Shape 98"/>
           <p:cNvSpPr/>
           <p:nvPr/>
         </p:nvSpPr>
@@ -4240,7 +4176,7 @@
       </p:sp>
       <p:sp>
         <p:nvSpPr>
-          <p:cNvPr id="104" name="Text 101"/>
+          <p:cNvPr id="102" name="Text 99"/>
           <p:cNvSpPr/>
           <p:nvPr/>
         </p:nvSpPr>
@@ -4279,7 +4215,7 @@
       </p:sp>
       <p:sp>
         <p:nvSpPr>
-          <p:cNvPr id="105" name="Shape 102"/>
+          <p:cNvPr id="103" name="Shape 100"/>
           <p:cNvSpPr/>
           <p:nvPr/>
         </p:nvSpPr>
@@ -4304,7 +4240,7 @@
       </p:sp>
       <p:sp>
         <p:nvSpPr>
-          <p:cNvPr id="106" name="Text 103"/>
+          <p:cNvPr id="104" name="Text 101"/>
           <p:cNvSpPr/>
           <p:nvPr/>
         </p:nvSpPr>
@@ -4343,7 +4279,7 @@
       </p:sp>
       <p:sp>
         <p:nvSpPr>
-          <p:cNvPr id="107" name="Shape 104"/>
+          <p:cNvPr id="105" name="Shape 102"/>
           <p:cNvSpPr/>
           <p:nvPr/>
         </p:nvSpPr>
@@ -4367,7 +4303,7 @@
       </p:sp>
       <p:sp>
         <p:nvSpPr>
-          <p:cNvPr id="108" name="Text 105"/>
+          <p:cNvPr id="106" name="Text 103"/>
           <p:cNvSpPr/>
           <p:nvPr/>
         </p:nvSpPr>
@@ -4398,7 +4334,7 @@
                 <a:ea typeface="Arial" pitchFamily="34" charset="-122"/>
                 <a:cs typeface="Arial" pitchFamily="34" charset="-120"/>
               </a:rPr>
-              <a:t>COGCON MVP is nested within the performance-cognition strand (dashed link). It develops selected elements of Performance Under Pressure — not a complete Combat Mindset programme or a validated operational-readiness measure.</a:t>
+              <a:t>COGCON MVP is nested within the performance-cognition pillar (dashed link). It develops selected elements of Performance Under Pressure — not a complete Combat Mindset programme or a validated operational-readiness measure.</a:t>
             </a:r>
             <a:endParaRPr lang="en-US" sz="680" dirty="0"/>
           </a:p>
@@ -4406,7 +4342,7 @@
       </p:sp>
       <p:sp>
         <p:nvSpPr>
-          <p:cNvPr id="109" name="Text 106"/>
+          <p:cNvPr id="107" name="Text 104"/>
           <p:cNvSpPr/>
           <p:nvPr/>
         </p:nvSpPr>
@@ -4437,7 +4373,7 @@
                 <a:ea typeface="Arial" pitchFamily="34" charset="-122"/>
                 <a:cs typeface="Arial" pitchFamily="34" charset="-120"/>
               </a:rPr>
-              <a:t>Prepare → Perform → Recover   ·   Lead Self → Lead Teams → Lead Leaders → Lead Systems</a:t>
+              <a:t>Prepare ► Perform ► Recover   ·   Lead Self ► Lead Teams ► Lead Leaders ► Lead Systems</a:t>
             </a:r>
             <a:endParaRPr lang="en-US" sz="680" dirty="0"/>
           </a:p>

</xml_diff>